<commit_message>
Rename MASTER_SHOT_TABLE to DEMO_TABLE and fix SQLite compatibility
- Rename all references from MASTER_SHOT_TABLE to DEMO_TABLE across 60+ files
- Rename module file, pipeline directory, CSV file, and function names
- Add MODE() aggregate function support for SQLite local fallback
- Add MOLD_MAINTENANCE/MOLD_LOCATION empty table stubs for local mode
- Add ::TIMESTAMP cast and NULLS LAST/FIRST translation for SQLite
- Fix mold_tools query to use actual CSV columns
- Remove print statement from pareto_downtime
</commit_message>
<xml_diff>
--- a/ppt/Prototype Submission Template _ Cortex Code CLI Hackathon.pptx
+++ b/ppt/Prototype Submission Template _ Cortex Code CLI Hackathon.pptx
@@ -7662,7 +7662,7 @@
               </a:defRPr>
             </a:pPr>
             <a:r>
-              <a:t>Data Source: MMS_DEMO.PUBLIC.MASTER_SHOT_TABLE (Snowflake) - 243K rows, 8 machines</a:t>
+              <a:t>Data Source: MMS_DEMO.PUBLIC.DEMO_SHOTS (Snowflake) - 243K rows, 8 machines</a:t>
             </a:r>
           </a:p>
           <a:p>
@@ -7695,7 +7695,7 @@
               </a:defRPr>
             </a:pPr>
             <a:r>
-              <a:t>Snowflake Tables (MASTER_SHOT_TABLE, MOLD, SHIFT_NOTE, WORK_ORDER),</a:t>
+              <a:t>Snowflake Tables (DEMO_SHOTS, MOLD, SHIFT_NOTE, WORK_ORDER),</a:t>
             </a:r>
           </a:p>
           <a:p>

</xml_diff>